<commit_message>
Day 2 rebuild in the Day 1 style: merged engine, Day 1 KPI sequence, 19 decks rebuilt
house.mjs is now the Day 1 Meeting Builder engine plus every Day 2 renderer,
option and metric (neutral, benchmark/extra columns, rate formats, words guard),
refitted to the Day 1 body geometry. blocks.mjs runs group picture -> level ->
change with Day 1 period labels. Store names Title Case in takeaways.
v1 decks are untouched in decks/v1 - house style/.

Co-Authored-By: Claude Opus 5.5 <noreply@anthropic.com>
Claude-Session: https://claude.ai/code/session_01Xa4nFVxuQGXmHARGph9WhS
</commit_message>
<xml_diff>
--- a/day2-deck/decks/Best Techs - Design Options.pptx
+++ b/day2-deck/decks/Best Techs - Design Options.pptx
@@ -3436,8 +3436,8 @@
         </p:nvSpPr>
         <p:spPr>
           <a:xfrm>
-            <a:off x="457200" y="5961888"/>
-            <a:ext cx="11274552" cy="548640"/>
+            <a:off x="457200" y="6126480"/>
+            <a:ext cx="11274552" cy="615696"/>
           </a:xfrm>
           <a:prstGeom prst="rect">
             <a:avLst/>
@@ -3456,8 +3456,8 @@
         </p:nvSpPr>
         <p:spPr>
           <a:xfrm>
-            <a:off x="658368" y="5980176"/>
-            <a:ext cx="10927080" cy="512064"/>
+            <a:off x="658368" y="6144768"/>
+            <a:ext cx="10927080" cy="579120"/>
           </a:xfrm>
           <a:prstGeom prst="rect">
             <a:avLst/>
@@ -7272,8 +7272,8 @@
         </p:nvSpPr>
         <p:spPr>
           <a:xfrm>
-            <a:off x="457200" y="5961888"/>
-            <a:ext cx="11274552" cy="548640"/>
+            <a:off x="457200" y="6126480"/>
+            <a:ext cx="11274552" cy="615696"/>
           </a:xfrm>
           <a:prstGeom prst="rect">
             <a:avLst/>
@@ -7292,8 +7292,8 @@
         </p:nvSpPr>
         <p:spPr>
           <a:xfrm>
-            <a:off x="658368" y="5980176"/>
-            <a:ext cx="10927080" cy="512064"/>
+            <a:off x="658368" y="6144768"/>
+            <a:ext cx="10927080" cy="579120"/>
           </a:xfrm>
           <a:prstGeom prst="rect">
             <a:avLst/>
@@ -9505,8 +9505,8 @@
         </p:nvSpPr>
         <p:spPr>
           <a:xfrm>
-            <a:off x="457200" y="5961888"/>
-            <a:ext cx="11274552" cy="548640"/>
+            <a:off x="457200" y="6126480"/>
+            <a:ext cx="11274552" cy="615696"/>
           </a:xfrm>
           <a:prstGeom prst="rect">
             <a:avLst/>
@@ -9525,8 +9525,8 @@
         </p:nvSpPr>
         <p:spPr>
           <a:xfrm>
-            <a:off x="658368" y="5980176"/>
-            <a:ext cx="10927080" cy="512064"/>
+            <a:off x="658368" y="6144768"/>
+            <a:ext cx="10927080" cy="579120"/>
           </a:xfrm>
           <a:prstGeom prst="rect">
             <a:avLst/>

</xml_diff>

<commit_message>
Proficiency: worked hours, not paid hours; readable Most Improved grids; trim Open Decisions
- Every proficiency slide and note says worked hours (techs are flat rate)
- How We Measured It: drop the INEOS line, expand who counts
- Better Than Last Year / Who's Moving Now grids: top and bottom 3, larger rows
- Open Decisions: remove door rate options C-E and Best Techs A-B

Co-Authored-By: Claude Opus 5.5 <noreply@anthropic.com>
Claude-Session: https://claude.ai/code/session_01Xa4nFVxuQGXmHARGph9WhS
</commit_message>
<xml_diff>
--- a/day2-deck/decks/Best Techs - Design Options.pptx
+++ b/day2-deck/decks/Best Techs - Design Options.pptx
@@ -504,7 +504,7 @@
           <a:p>
             <a:r>
               <a:rPr lang="en-US" dirty="0"/>
-              <a:t>Source: Stores under 85% only. Store = sold / paid hours for counted technicians. Best techs = the store's most proficient quarter of counted technicians (at least one), their sold / paid hours combined. Same population and rules as the proficiency slides.
+              <a:t>Source: Stores under 85% only. Store = sold / worked hours for counted technicians. Best techs = the store's most proficient quarter of counted technicians (at least one), their sold / worked hours combined. Same population and rules as the proficiency slides.
 ACURA: store 67%, best 3 of 11 techs 73%
 KIA ST GEORGE: store 67%, best 3 of 12 techs 97%
 CHEVY GMC BULLHEAD: store 68%, best 5 of 20 techs 96%
@@ -605,7 +605,7 @@
           <a:p>
             <a:r>
               <a:rPr lang="en-US" dirty="0"/>
-              <a:t>Source: Stores under 85% only. Store = sold / paid hours for counted technicians. Best techs = the store's most proficient quarter of counted technicians (at least one), their sold / paid hours combined. Same population and rules as the proficiency slides.
+              <a:t>Source: Stores under 85% only. Store = sold / worked hours for counted technicians. Best techs = the store's most proficient quarter of counted technicians (at least one), their sold / worked hours combined. Same population and rules as the proficiency slides.
 ACURA: store 67%, best 3 of 11 techs 73%
 KIA ST GEORGE: store 67%, best 3 of 12 techs 97%
 CHEVY GMC BULLHEAD: store 68%, best 5 of 20 techs 96%
@@ -706,7 +706,7 @@
           <a:p>
             <a:r>
               <a:rPr lang="en-US" dirty="0"/>
-              <a:t>Source: Stores under 85% only. Store = sold / paid hours for counted technicians. Best techs = the store's most proficient quarter of counted technicians (at least one), their sold / paid hours combined. Same population and rules as the proficiency slides.
+              <a:t>Source: Stores under 85% only. Store = sold / worked hours for counted technicians. Best techs = the store's most proficient quarter of counted technicians (at least one), their sold / worked hours combined. Same population and rules as the proficiency slides.
 ACURA: store 67%, best 3 of 11 techs 73%
 KIA ST GEORGE: store 67%, best 3 of 12 techs 97%
 CHEVY GMC BULLHEAD: store 68%, best 5 of 20 techs 96%

</xml_diff>